<commit_message>
Small tweaks to Flash Template, removed deliquency audit
</commit_message>
<xml_diff>
--- a/storeinsight/public/FLASHTEMPLATE.pptx
+++ b/storeinsight/public/FLASHTEMPLATE.pptx
@@ -6885,7 +6885,7 @@
               </a:lnSpc>
             </a:pPr>
             <a:r>
-              <a:rPr lang="en-US" sz="700" dirty="0">
+              <a:rPr lang="en-US" sz="700" i="1" dirty="0">
                 <a:solidFill>
                   <a:srgbClr val="2D2D2D"/>
                 </a:solidFill>
@@ -6897,7 +6897,7 @@
               <a:t>Total income from occupied space at in-place rents, including approved rate increases</a:t>
             </a:r>
             <a:r>
-              <a:rPr lang="en-US" sz="700" dirty="0">
+              <a:rPr lang="en-US" sz="700" i="1" dirty="0">
                 <a:solidFill>
                   <a:srgbClr val="2D2D2D"/>
                 </a:solidFill>
@@ -6912,7 +6912,7 @@
               </a:lnSpc>
             </a:pPr>
             <a:r>
-              <a:rPr lang="en-US" sz="700" dirty="0">
+              <a:rPr lang="en-US" sz="700" i="1" dirty="0">
                 <a:solidFill>
                   <a:srgbClr val="2D2D2D"/>
                 </a:solidFill>
@@ -6922,7 +6922,7 @@
               <a:t>Total income if all vacant spaces were leased at the sell (current) rate plus </a:t>
             </a:r>
             <a:r>
-              <a:rPr lang="en-US" sz="700" dirty="0" err="1">
+              <a:rPr lang="en-US" sz="700" i="1" dirty="0" err="1">
                 <a:solidFill>
                   <a:srgbClr val="2D2D2D"/>
                 </a:solidFill>
@@ -6932,7 +6932,7 @@
               <a:t>proj</a:t>
             </a:r>
             <a:r>
-              <a:rPr lang="en-US" sz="700" dirty="0">
+              <a:rPr lang="en-US" sz="700" i="1" dirty="0">
                 <a:solidFill>
                   <a:srgbClr val="2D2D2D"/>
                 </a:solidFill>
@@ -6942,7 +6942,7 @@
               <a:t>. rent</a:t>
             </a:r>
             <a:r>
-              <a:rPr lang="en-US" sz="700" dirty="0">
+              <a:rPr lang="en-US" sz="700" i="1" dirty="0">
                 <a:solidFill>
                   <a:srgbClr val="2D2D2D"/>
                 </a:solidFill>
@@ -6957,7 +6957,7 @@
               </a:lnSpc>
             </a:pPr>
             <a:r>
-              <a:rPr lang="en-US" sz="700" dirty="0">
+              <a:rPr lang="en-US" sz="700" i="1" dirty="0">
                 <a:solidFill>
                   <a:srgbClr val="2D2D2D"/>
                 </a:solidFill>
@@ -6969,14 +6969,14 @@
               <a:t>Projected total income assuming 100% occupancy at the set (target) rental rates</a:t>
             </a:r>
             <a:r>
-              <a:rPr lang="en-US" sz="700" dirty="0">
+              <a:rPr lang="en-US" sz="700" i="1" dirty="0">
                 <a:solidFill>
                   <a:srgbClr val="2D2D2D"/>
                 </a:solidFill>
               </a:rPr>
               <a:t>³</a:t>
             </a:r>
-            <a:endParaRPr lang="en-US" sz="700" dirty="0">
+            <a:endParaRPr lang="en-US" sz="700" i="1" dirty="0">
               <a:solidFill>
                 <a:srgbClr val="2D2D2D"/>
               </a:solidFill>

</xml_diff>

<commit_message>
New charts for daily flash reports
</commit_message>
<xml_diff>
--- a/storeinsight/public/FLASHTEMPLATE.pptx
+++ b/storeinsight/public/FLASHTEMPLATE.pptx
@@ -6631,8 +6631,8 @@
         </p:nvSpPr>
         <p:spPr>
           <a:xfrm>
-            <a:off x="586152" y="6196038"/>
-            <a:ext cx="3223848" cy="2058878"/>
+            <a:off x="586150" y="6196038"/>
+            <a:ext cx="3223850" cy="2058878"/>
           </a:xfrm>
           <a:custGeom>
             <a:avLst/>
@@ -6685,7 +6685,7 @@
         <p:spPr>
           <a:xfrm>
             <a:off x="3962401" y="6196038"/>
-            <a:ext cx="3223848" cy="2058878"/>
+            <a:ext cx="3233722" cy="2058878"/>
           </a:xfrm>
           <a:custGeom>
             <a:avLst/>

</xml_diff>

<commit_message>
3rd part of flash improvements
</commit_message>
<xml_diff>
--- a/storeinsight/public/FLASHTEMPLATE.pptx
+++ b/storeinsight/public/FLASHTEMPLATE.pptx
@@ -313,7 +313,7 @@
             <a:fld id="{1D8BD707-D9CF-40AE-B4C6-C98DA3205C09}" type="datetimeFigureOut">
               <a:rPr lang="en-US" smtClean="0"/>
               <a:pPr/>
-              <a:t>1/15/2026</a:t>
+              <a:t>1/16/2026</a:t>
             </a:fld>
             <a:endParaRPr lang="en-US"/>
           </a:p>
@@ -478,7 +478,7 @@
             <a:fld id="{1D8BD707-D9CF-40AE-B4C6-C98DA3205C09}" type="datetimeFigureOut">
               <a:rPr lang="en-US" smtClean="0"/>
               <a:pPr/>
-              <a:t>1/15/2026</a:t>
+              <a:t>1/16/2026</a:t>
             </a:fld>
             <a:endParaRPr lang="en-US"/>
           </a:p>
@@ -653,7 +653,7 @@
             <a:fld id="{1D8BD707-D9CF-40AE-B4C6-C98DA3205C09}" type="datetimeFigureOut">
               <a:rPr lang="en-US" smtClean="0"/>
               <a:pPr/>
-              <a:t>1/15/2026</a:t>
+              <a:t>1/16/2026</a:t>
             </a:fld>
             <a:endParaRPr lang="en-US"/>
           </a:p>
@@ -818,7 +818,7 @@
             <a:fld id="{1D8BD707-D9CF-40AE-B4C6-C98DA3205C09}" type="datetimeFigureOut">
               <a:rPr lang="en-US" smtClean="0"/>
               <a:pPr/>
-              <a:t>1/15/2026</a:t>
+              <a:t>1/16/2026</a:t>
             </a:fld>
             <a:endParaRPr lang="en-US"/>
           </a:p>
@@ -1060,7 +1060,7 @@
             <a:fld id="{1D8BD707-D9CF-40AE-B4C6-C98DA3205C09}" type="datetimeFigureOut">
               <a:rPr lang="en-US" smtClean="0"/>
               <a:pPr/>
-              <a:t>1/15/2026</a:t>
+              <a:t>1/16/2026</a:t>
             </a:fld>
             <a:endParaRPr lang="en-US"/>
           </a:p>
@@ -1342,7 +1342,7 @@
             <a:fld id="{1D8BD707-D9CF-40AE-B4C6-C98DA3205C09}" type="datetimeFigureOut">
               <a:rPr lang="en-US" smtClean="0"/>
               <a:pPr/>
-              <a:t>1/15/2026</a:t>
+              <a:t>1/16/2026</a:t>
             </a:fld>
             <a:endParaRPr lang="en-US"/>
           </a:p>
@@ -1758,7 +1758,7 @@
             <a:fld id="{1D8BD707-D9CF-40AE-B4C6-C98DA3205C09}" type="datetimeFigureOut">
               <a:rPr lang="en-US" smtClean="0"/>
               <a:pPr/>
-              <a:t>1/15/2026</a:t>
+              <a:t>1/16/2026</a:t>
             </a:fld>
             <a:endParaRPr lang="en-US"/>
           </a:p>
@@ -1872,7 +1872,7 @@
             <a:fld id="{1D8BD707-D9CF-40AE-B4C6-C98DA3205C09}" type="datetimeFigureOut">
               <a:rPr lang="en-US" smtClean="0"/>
               <a:pPr/>
-              <a:t>1/15/2026</a:t>
+              <a:t>1/16/2026</a:t>
             </a:fld>
             <a:endParaRPr lang="en-US"/>
           </a:p>
@@ -1964,7 +1964,7 @@
             <a:fld id="{1D8BD707-D9CF-40AE-B4C6-C98DA3205C09}" type="datetimeFigureOut">
               <a:rPr lang="en-US" smtClean="0"/>
               <a:pPr/>
-              <a:t>1/15/2026</a:t>
+              <a:t>1/16/2026</a:t>
             </a:fld>
             <a:endParaRPr lang="en-US"/>
           </a:p>
@@ -2236,7 +2236,7 @@
             <a:fld id="{1D8BD707-D9CF-40AE-B4C6-C98DA3205C09}" type="datetimeFigureOut">
               <a:rPr lang="en-US" smtClean="0"/>
               <a:pPr/>
-              <a:t>1/15/2026</a:t>
+              <a:t>1/16/2026</a:t>
             </a:fld>
             <a:endParaRPr lang="en-US"/>
           </a:p>
@@ -2485,7 +2485,7 @@
             <a:fld id="{1D8BD707-D9CF-40AE-B4C6-C98DA3205C09}" type="datetimeFigureOut">
               <a:rPr lang="en-US" smtClean="0"/>
               <a:pPr/>
-              <a:t>1/15/2026</a:t>
+              <a:t>1/16/2026</a:t>
             </a:fld>
             <a:endParaRPr lang="en-US"/>
           </a:p>
@@ -2693,7 +2693,7 @@
             <a:fld id="{1D8BD707-D9CF-40AE-B4C6-C98DA3205C09}" type="datetimeFigureOut">
               <a:rPr lang="en-US" smtClean="0"/>
               <a:pPr/>
-              <a:t>1/15/2026</a:t>
+              <a:t>1/16/2026</a:t>
             </a:fld>
             <a:endParaRPr lang="en-US"/>
           </a:p>
@@ -6631,8 +6631,8 @@
         </p:nvSpPr>
         <p:spPr>
           <a:xfrm>
-            <a:off x="586150" y="6196038"/>
-            <a:ext cx="3223850" cy="2058878"/>
+            <a:off x="586150" y="6093984"/>
+            <a:ext cx="3223850" cy="2160932"/>
           </a:xfrm>
           <a:custGeom>
             <a:avLst/>
@@ -6684,8 +6684,8 @@
         </p:nvSpPr>
         <p:spPr>
           <a:xfrm>
-            <a:off x="3962401" y="6196038"/>
-            <a:ext cx="3233722" cy="2058878"/>
+            <a:off x="3962401" y="6093985"/>
+            <a:ext cx="3233722" cy="2160932"/>
           </a:xfrm>
           <a:custGeom>
             <a:avLst/>
@@ -6778,8 +6778,8 @@
         </p:nvSpPr>
         <p:spPr>
           <a:xfrm>
-            <a:off x="1736648" y="6019800"/>
-            <a:ext cx="930352" cy="121252"/>
+            <a:off x="1580499" y="5963233"/>
+            <a:ext cx="1238901" cy="121252"/>
           </a:xfrm>
           <a:prstGeom prst="rect">
             <a:avLst/>
@@ -6806,7 +6806,7 @@
                 <a:cs typeface="Avenir"/>
                 <a:sym typeface="Avenir"/>
               </a:rPr>
-              <a:t>Net Rental Income</a:t>
+              <a:t>Net Rental Income (MoM)</a:t>
             </a:r>
           </a:p>
         </p:txBody>
@@ -6819,8 +6819,8 @@
         </p:nvSpPr>
         <p:spPr>
           <a:xfrm>
-            <a:off x="5181600" y="6019800"/>
-            <a:ext cx="930352" cy="121252"/>
+            <a:off x="5029200" y="5965032"/>
+            <a:ext cx="1238901" cy="121252"/>
           </a:xfrm>
           <a:prstGeom prst="rect">
             <a:avLst/>
@@ -6847,7 +6847,7 @@
                 <a:cs typeface="Avenir"/>
                 <a:sym typeface="Avenir"/>
               </a:rPr>
-              <a:t>Overall Occupancy</a:t>
+              <a:t>Overall Occupancy (MoM)</a:t>
             </a:r>
           </a:p>
         </p:txBody>

</xml_diff>

<commit_message>
Added .xlsx export option to Comp Set page
</commit_message>
<xml_diff>
--- a/storeinsight/public/FLASHTEMPLATE.pptx
+++ b/storeinsight/public/FLASHTEMPLATE.pptx
@@ -313,7 +313,7 @@
             <a:fld id="{1D8BD707-D9CF-40AE-B4C6-C98DA3205C09}" type="datetimeFigureOut">
               <a:rPr lang="en-US" smtClean="0"/>
               <a:pPr/>
-              <a:t>2/6/2026</a:t>
+              <a:t>3/2/2026</a:t>
             </a:fld>
             <a:endParaRPr lang="en-US"/>
           </a:p>
@@ -478,7 +478,7 @@
             <a:fld id="{1D8BD707-D9CF-40AE-B4C6-C98DA3205C09}" type="datetimeFigureOut">
               <a:rPr lang="en-US" smtClean="0"/>
               <a:pPr/>
-              <a:t>2/6/2026</a:t>
+              <a:t>3/2/2026</a:t>
             </a:fld>
             <a:endParaRPr lang="en-US"/>
           </a:p>
@@ -653,7 +653,7 @@
             <a:fld id="{1D8BD707-D9CF-40AE-B4C6-C98DA3205C09}" type="datetimeFigureOut">
               <a:rPr lang="en-US" smtClean="0"/>
               <a:pPr/>
-              <a:t>2/6/2026</a:t>
+              <a:t>3/2/2026</a:t>
             </a:fld>
             <a:endParaRPr lang="en-US"/>
           </a:p>
@@ -818,7 +818,7 @@
             <a:fld id="{1D8BD707-D9CF-40AE-B4C6-C98DA3205C09}" type="datetimeFigureOut">
               <a:rPr lang="en-US" smtClean="0"/>
               <a:pPr/>
-              <a:t>2/6/2026</a:t>
+              <a:t>3/2/2026</a:t>
             </a:fld>
             <a:endParaRPr lang="en-US"/>
           </a:p>
@@ -1060,7 +1060,7 @@
             <a:fld id="{1D8BD707-D9CF-40AE-B4C6-C98DA3205C09}" type="datetimeFigureOut">
               <a:rPr lang="en-US" smtClean="0"/>
               <a:pPr/>
-              <a:t>2/6/2026</a:t>
+              <a:t>3/2/2026</a:t>
             </a:fld>
             <a:endParaRPr lang="en-US"/>
           </a:p>
@@ -1342,7 +1342,7 @@
             <a:fld id="{1D8BD707-D9CF-40AE-B4C6-C98DA3205C09}" type="datetimeFigureOut">
               <a:rPr lang="en-US" smtClean="0"/>
               <a:pPr/>
-              <a:t>2/6/2026</a:t>
+              <a:t>3/2/2026</a:t>
             </a:fld>
             <a:endParaRPr lang="en-US"/>
           </a:p>
@@ -1758,7 +1758,7 @@
             <a:fld id="{1D8BD707-D9CF-40AE-B4C6-C98DA3205C09}" type="datetimeFigureOut">
               <a:rPr lang="en-US" smtClean="0"/>
               <a:pPr/>
-              <a:t>2/6/2026</a:t>
+              <a:t>3/2/2026</a:t>
             </a:fld>
             <a:endParaRPr lang="en-US"/>
           </a:p>
@@ -1872,7 +1872,7 @@
             <a:fld id="{1D8BD707-D9CF-40AE-B4C6-C98DA3205C09}" type="datetimeFigureOut">
               <a:rPr lang="en-US" smtClean="0"/>
               <a:pPr/>
-              <a:t>2/6/2026</a:t>
+              <a:t>3/2/2026</a:t>
             </a:fld>
             <a:endParaRPr lang="en-US"/>
           </a:p>
@@ -1964,7 +1964,7 @@
             <a:fld id="{1D8BD707-D9CF-40AE-B4C6-C98DA3205C09}" type="datetimeFigureOut">
               <a:rPr lang="en-US" smtClean="0"/>
               <a:pPr/>
-              <a:t>2/6/2026</a:t>
+              <a:t>3/2/2026</a:t>
             </a:fld>
             <a:endParaRPr lang="en-US"/>
           </a:p>
@@ -2236,7 +2236,7 @@
             <a:fld id="{1D8BD707-D9CF-40AE-B4C6-C98DA3205C09}" type="datetimeFigureOut">
               <a:rPr lang="en-US" smtClean="0"/>
               <a:pPr/>
-              <a:t>2/6/2026</a:t>
+              <a:t>3/2/2026</a:t>
             </a:fld>
             <a:endParaRPr lang="en-US"/>
           </a:p>
@@ -2485,7 +2485,7 @@
             <a:fld id="{1D8BD707-D9CF-40AE-B4C6-C98DA3205C09}" type="datetimeFigureOut">
               <a:rPr lang="en-US" smtClean="0"/>
               <a:pPr/>
-              <a:t>2/6/2026</a:t>
+              <a:t>3/2/2026</a:t>
             </a:fld>
             <a:endParaRPr lang="en-US"/>
           </a:p>
@@ -2693,7 +2693,7 @@
             <a:fld id="{1D8BD707-D9CF-40AE-B4C6-C98DA3205C09}" type="datetimeFigureOut">
               <a:rPr lang="en-US" smtClean="0"/>
               <a:pPr/>
-              <a:t>2/6/2026</a:t>
+              <a:t>3/2/2026</a:t>
             </a:fld>
             <a:endParaRPr lang="en-US"/>
           </a:p>
@@ -6791,7 +6791,7 @@
           </a:bodyPr>
           <a:lstStyle/>
           <a:p>
-            <a:pPr algn="l">
+            <a:pPr algn="ctr">
               <a:lnSpc>
                 <a:spcPts val="963"/>
               </a:lnSpc>
@@ -6806,7 +6806,7 @@
                 <a:cs typeface="Avenir"/>
                 <a:sym typeface="Avenir"/>
               </a:rPr>
-              <a:t>Net Rental Income (MoM)</a:t>
+              <a:t>Net Rental Income</a:t>
             </a:r>
           </a:p>
         </p:txBody>
@@ -6832,13 +6832,13 @@
           </a:bodyPr>
           <a:lstStyle/>
           <a:p>
-            <a:pPr algn="l">
+            <a:pPr algn="ctr">
               <a:lnSpc>
                 <a:spcPts val="963"/>
               </a:lnSpc>
             </a:pPr>
             <a:r>
-              <a:rPr lang="en-US" sz="802">
+              <a:rPr lang="en-US" sz="802" dirty="0">
                 <a:solidFill>
                   <a:srgbClr val="2D2D2D"/>
                 </a:solidFill>
@@ -6847,17 +6847,8 @@
                 <a:cs typeface="Avenir"/>
                 <a:sym typeface="Avenir"/>
               </a:rPr>
-              <a:t>Occupancy / RSF (MoM)</a:t>
-            </a:r>
-            <a:endParaRPr lang="en-US" sz="802" dirty="0">
-              <a:solidFill>
-                <a:srgbClr val="2D2D2D"/>
-              </a:solidFill>
-              <a:latin typeface="Avenir"/>
-              <a:ea typeface="Avenir"/>
-              <a:cs typeface="Avenir"/>
-              <a:sym typeface="Avenir"/>
-            </a:endParaRPr>
+              <a:t>Occupancy / RSF</a:t>
+            </a:r>
           </a:p>
         </p:txBody>
       </p:sp>

</xml_diff>

<commit_message>
New OSR logic for uploading and parsing
</commit_message>
<xml_diff>
--- a/storeinsight/public/FLASHTEMPLATE.pptx
+++ b/storeinsight/public/FLASHTEMPLATE.pptx
@@ -17,6 +17,7 @@
     <p:embeddedFont>
       <p:font typeface="Avenir Bold" panose="020B0604020202020204" charset="0"/>
       <p:regular r:id="rId4"/>
+      <p:bold r:id="rId5"/>
     </p:embeddedFont>
   </p:embeddedFontLst>
   <p:defaultTextStyle>
@@ -313,7 +314,7 @@
             <a:fld id="{1D8BD707-D9CF-40AE-B4C6-C98DA3205C09}" type="datetimeFigureOut">
               <a:rPr lang="en-US" smtClean="0"/>
               <a:pPr/>
-              <a:t>4/29/2026</a:t>
+              <a:t>6/18/2026</a:t>
             </a:fld>
             <a:endParaRPr lang="en-US"/>
           </a:p>
@@ -478,7 +479,7 @@
             <a:fld id="{1D8BD707-D9CF-40AE-B4C6-C98DA3205C09}" type="datetimeFigureOut">
               <a:rPr lang="en-US" smtClean="0"/>
               <a:pPr/>
-              <a:t>4/29/2026</a:t>
+              <a:t>6/18/2026</a:t>
             </a:fld>
             <a:endParaRPr lang="en-US"/>
           </a:p>
@@ -653,7 +654,7 @@
             <a:fld id="{1D8BD707-D9CF-40AE-B4C6-C98DA3205C09}" type="datetimeFigureOut">
               <a:rPr lang="en-US" smtClean="0"/>
               <a:pPr/>
-              <a:t>4/29/2026</a:t>
+              <a:t>6/18/2026</a:t>
             </a:fld>
             <a:endParaRPr lang="en-US"/>
           </a:p>
@@ -818,7 +819,7 @@
             <a:fld id="{1D8BD707-D9CF-40AE-B4C6-C98DA3205C09}" type="datetimeFigureOut">
               <a:rPr lang="en-US" smtClean="0"/>
               <a:pPr/>
-              <a:t>4/29/2026</a:t>
+              <a:t>6/18/2026</a:t>
             </a:fld>
             <a:endParaRPr lang="en-US"/>
           </a:p>
@@ -1060,7 +1061,7 @@
             <a:fld id="{1D8BD707-D9CF-40AE-B4C6-C98DA3205C09}" type="datetimeFigureOut">
               <a:rPr lang="en-US" smtClean="0"/>
               <a:pPr/>
-              <a:t>4/29/2026</a:t>
+              <a:t>6/18/2026</a:t>
             </a:fld>
             <a:endParaRPr lang="en-US"/>
           </a:p>
@@ -1342,7 +1343,7 @@
             <a:fld id="{1D8BD707-D9CF-40AE-B4C6-C98DA3205C09}" type="datetimeFigureOut">
               <a:rPr lang="en-US" smtClean="0"/>
               <a:pPr/>
-              <a:t>4/29/2026</a:t>
+              <a:t>6/18/2026</a:t>
             </a:fld>
             <a:endParaRPr lang="en-US"/>
           </a:p>
@@ -1758,7 +1759,7 @@
             <a:fld id="{1D8BD707-D9CF-40AE-B4C6-C98DA3205C09}" type="datetimeFigureOut">
               <a:rPr lang="en-US" smtClean="0"/>
               <a:pPr/>
-              <a:t>4/29/2026</a:t>
+              <a:t>6/18/2026</a:t>
             </a:fld>
             <a:endParaRPr lang="en-US"/>
           </a:p>
@@ -1872,7 +1873,7 @@
             <a:fld id="{1D8BD707-D9CF-40AE-B4C6-C98DA3205C09}" type="datetimeFigureOut">
               <a:rPr lang="en-US" smtClean="0"/>
               <a:pPr/>
-              <a:t>4/29/2026</a:t>
+              <a:t>6/18/2026</a:t>
             </a:fld>
             <a:endParaRPr lang="en-US"/>
           </a:p>
@@ -1964,7 +1965,7 @@
             <a:fld id="{1D8BD707-D9CF-40AE-B4C6-C98DA3205C09}" type="datetimeFigureOut">
               <a:rPr lang="en-US" smtClean="0"/>
               <a:pPr/>
-              <a:t>4/29/2026</a:t>
+              <a:t>6/18/2026</a:t>
             </a:fld>
             <a:endParaRPr lang="en-US"/>
           </a:p>
@@ -2236,7 +2237,7 @@
             <a:fld id="{1D8BD707-D9CF-40AE-B4C6-C98DA3205C09}" type="datetimeFigureOut">
               <a:rPr lang="en-US" smtClean="0"/>
               <a:pPr/>
-              <a:t>4/29/2026</a:t>
+              <a:t>6/18/2026</a:t>
             </a:fld>
             <a:endParaRPr lang="en-US"/>
           </a:p>
@@ -2485,7 +2486,7 @@
             <a:fld id="{1D8BD707-D9CF-40AE-B4C6-C98DA3205C09}" type="datetimeFigureOut">
               <a:rPr lang="en-US" smtClean="0"/>
               <a:pPr/>
-              <a:t>4/29/2026</a:t>
+              <a:t>6/18/2026</a:t>
             </a:fld>
             <a:endParaRPr lang="en-US"/>
           </a:p>
@@ -2693,7 +2694,7 @@
             <a:fld id="{1D8BD707-D9CF-40AE-B4C6-C98DA3205C09}" type="datetimeFigureOut">
               <a:rPr lang="en-US" smtClean="0"/>
               <a:pPr/>
-              <a:t>4/29/2026</a:t>
+              <a:t>6/18/2026</a:t>
             </a:fld>
             <a:endParaRPr lang="en-US"/>
           </a:p>
@@ -6797,7 +6798,7 @@
               </a:lnSpc>
             </a:pPr>
             <a:r>
-              <a:rPr lang="en-US" sz="802" dirty="0">
+              <a:rPr lang="en-US" sz="802">
                 <a:solidFill>
                   <a:srgbClr val="2D2D2D"/>
                 </a:solidFill>
@@ -6806,8 +6807,17 @@
                 <a:cs typeface="Avenir"/>
                 <a:sym typeface="Avenir"/>
               </a:rPr>
-              <a:t>Net Revenue</a:t>
-            </a:r>
+              <a:t>Total Revenue</a:t>
+            </a:r>
+            <a:endParaRPr lang="en-US" sz="802" dirty="0">
+              <a:solidFill>
+                <a:srgbClr val="2D2D2D"/>
+              </a:solidFill>
+              <a:latin typeface="Avenir"/>
+              <a:ea typeface="Avenir"/>
+              <a:cs typeface="Avenir"/>
+              <a:sym typeface="Avenir"/>
+            </a:endParaRPr>
           </a:p>
         </p:txBody>
       </p:sp>

</xml_diff>